<commit_message>
design: business model slide, cover refresh and deck PDF links
- Slide 6 is now "Why BCH, who pays": agent builders (hosted budget console), API and MCP tool
  providers (SDK and verifier for $0.01 PUSD calls) and a hosted gateway fee per verified call;
  the covenant stays fee-free. First market: paid MCP tools and data APIs.
- Slide 4 adds the covenant facts (3 spend paths, 21 VM tests) and a clearer role hierarchy.
- Slide 7 links the self-hosted Deck PDF instead of the blocked Google Slides copy.
- Slide 1 cover shows the current Mainnet-default UI; slides 2 and 5 no longer wrap mid-phrase.
- Re-rendered all 7 pages with the deck fonts (Roboto, Montserrat, Roboto Mono) into
  public/StreamVault-BCH-Blaze-2026.pdf and docs/deck.
- In-app deck: "Official deck (PDF)" link and the same who-pays copy.

Co-Authored-By: Claude Opus 5.5 <noreply@anthropic.com>
Claude-Session: https://claude.ai/code/session_016nzEgyts6no5Ww9kyctn64
</commit_message>
<xml_diff>
--- a/docs/deck/StreamVault-BCH-Blaze-2026-Submission.pptx
+++ b/docs/deck/StreamVault-BCH-Blaze-2026-Submission.pptx
@@ -1130,19 +1130,19 @@
           <a:bodyPr xmlns:a="http://schemas.openxmlformats.org/drawingml/2006/main"/>
           <a:lstStyle xmlns:a="http://schemas.openxmlformats.org/drawingml/2006/main"/>
           <a:p xmlns:a="http://schemas.openxmlformats.org/drawingml/2006/main">
-            <a:pPr marL="0" lvl="0" indent="0" algn="l">
-              <a:spcBef>
-                <a:spcPts val="0"/>
-              </a:spcBef>
-              <a:spcAft>
-                <a:spcPts val="0"/>
-              </a:spcAft>
-              <a:buNone/>
-            </a:pPr>
             <a:r>
-              <a:t>PUSD category: 2469acc5afa4b10cb5b5c04afb89c3a3ffd61c5da9c01e26d00951cae2a02544. The app blocks Mainnet if a demo category is configured.</a:t>
+              <a:t>Why BCH: sub-cent fees, CashTokens conservation, relative timelocks and WizardConnect.</a:t>
             </a:r>
-            <a:endParaRPr/>
+          </a:p>
+          <a:p xmlns:a="http://schemas.openxmlformats.org/drawingml/2006/main">
+            <a:r>
+              <a:t>Who pays: agent builders pay for the hosted budget console; API and MCP tool providers integrate the SDK and verifier to sell $0.01 PUSD calls; the hosted gateway charges a small fee per verified call. The covenant has no protocol fee, so self-hosting stays free.</a:t>
+            </a:r>
+          </a:p>
+          <a:p xmlns:a="http://schemas.openxmlformats.org/drawingml/2006/main">
+            <a:r>
+              <a:t>PUSD category: 2469acc5afa4b10cb5b5c04afb89c3a3ffd61c5da9c01e26d00951cae2a02544.</a:t>
+            </a:r>
           </a:p>
         </p:txBody>
       </p:sp>
@@ -1210,34 +1210,24 @@
           <a:bodyPr xmlns:a="http://schemas.openxmlformats.org/drawingml/2006/main"/>
           <a:lstStyle xmlns:a="http://schemas.openxmlformats.org/drawingml/2006/main"/>
           <a:p xmlns:a="http://schemas.openxmlformats.org/drawingml/2006/main">
-            <a:pPr marL="0" lvl="0" indent="0" algn="l">
-              <a:spcBef>
-                <a:spcPts val="0"/>
-              </a:spcBef>
-              <a:spcAft>
-                <a:spcPts val="0"/>
-              </a:spcAft>
-              <a:buNone/>
-            </a:pPr>
             <a:r>
               <a:t>Live demo: https://streamvault-cash.vercel.app</a:t>
             </a:r>
-            <a:endParaRPr/>
           </a:p>
           <a:p xmlns:a="http://schemas.openxmlformats.org/drawingml/2006/main">
-            <a:pPr marL="0" lvl="0" indent="0" algn="l">
-              <a:spcBef>
-                <a:spcPts val="0"/>
-              </a:spcBef>
-              <a:spcAft>
-                <a:spcPts val="0"/>
-              </a:spcAft>
-              <a:buNone/>
-            </a:pPr>
+            <a:r>
+              <a:t>Deck PDF: https://streamvault-cash.vercel.app/StreamVault-BCH-Blaze-2026.pdf</a:t>
+            </a:r>
+          </a:p>
+          <a:p xmlns:a="http://schemas.openxmlformats.org/drawingml/2006/main">
+            <a:r>
+              <a:t>Repository: https://github.com/juangh123/streamvault.cash</a:t>
+            </a:r>
+          </a:p>
+          <a:p xmlns:a="http://schemas.openxmlformats.org/drawingml/2006/main">
             <a:r>
               <a:t>CashTokens receiving address: bitcoincash:zzlgvjs8fvqdf43nz9yklcd0eh780x2xd5d9dxrnkv</a:t>
             </a:r>
-            <a:endParaRPr/>
           </a:p>
         </p:txBody>
       </p:sp>
@@ -7750,8 +7740,8 @@
         </p:nvSpPr>
         <p:spPr>
           <a:xfrm xmlns:a="http://schemas.openxmlformats.org/drawingml/2006/main">
-            <a:off x="857250" y="1000125"/>
-            <a:ext cx="7429500" cy="2000250"/>
+            <a:off x="411480" y="996696"/>
+            <a:ext cx="8321040" cy="2002536"/>
           </a:xfrm>
           <a:prstGeom xmlns:a="http://schemas.openxmlformats.org/drawingml/2006/main" prst="rect">
             <a:avLst/>
@@ -11392,189 +11382,141 @@
               </a:defRPr>
             </a:lvl9pPr>
           </a:lstStyle>
-          <a:p xmlns:a="http://schemas.openxmlformats.org/drawingml/2006/main">
-            <a:pPr marL="0" indent="0" algn="l">
-              <a:lnSpc>
-                <a:spcPct val="108000"/>
-              </a:lnSpc>
-              <a:spcAft>
-                <a:spcPts val="14"/>
-              </a:spcAft>
-              <a:buNone/>
-              <a:defRPr sz="1575" b="1">
-                <a:solidFill>
-                  <a:srgbClr val="FFFFFF"/>
-                </a:solidFill>
-                <a:latin typeface="Montserrat"/>
-                <a:ea typeface="Montserrat"/>
-                <a:cs typeface="Montserrat"/>
-              </a:defRPr>
-            </a:pPr>
-            <a:r>
-              <a:rPr sz="1575" b="1">
-                <a:solidFill>
-                  <a:srgbClr val="FFFFFF"/>
-                </a:solidFill>
-                <a:latin typeface="Montserrat"/>
-                <a:ea typeface="Montserrat"/>
-                <a:cs typeface="Montserrat"/>
-              </a:rPr>
-              <a:t>01  SPONSOR</a:t>
-            </a:r>
-            <a:br>
-              <a:rPr sz="1575" b="1">
-                <a:solidFill>
-                  <a:srgbClr val="FFFFFF"/>
-                </a:solidFill>
-                <a:latin typeface="Montserrat"/>
-                <a:ea typeface="Montserrat"/>
-                <a:cs typeface="Montserrat"/>
-              </a:rPr>
-            </a:br>
-            <a:r>
-              <a:rPr sz="1575" b="1">
-                <a:solidFill>
-                  <a:srgbClr val="FFFFFF"/>
-                </a:solidFill>
-                <a:latin typeface="Montserrat"/>
-                <a:ea typeface="Montserrat"/>
-                <a:cs typeface="Montserrat"/>
-              </a:rPr>
-              <a:t>Locks PUSD. Keeps cancel control.</a:t>
-            </a:r>
-          </a:p>
-          <a:p xmlns:a="http://schemas.openxmlformats.org/drawingml/2006/main">
-            <a:pPr marL="0" indent="0" algn="l">
-              <a:lnSpc>
-                <a:spcPct val="108000"/>
-              </a:lnSpc>
-              <a:spcAft>
-                <a:spcPts val="14"/>
-              </a:spcAft>
-              <a:buNone/>
-              <a:defRPr sz="1575" b="1">
-                <a:solidFill>
-                  <a:srgbClr val="FFFFFF"/>
-                </a:solidFill>
-                <a:latin typeface="Montserrat"/>
-                <a:ea typeface="Montserrat"/>
-                <a:cs typeface="Montserrat"/>
-              </a:defRPr>
-            </a:pPr>
-            <a:r>
-              <a:rPr sz="1575" b="1">
-                <a:solidFill>
-                  <a:srgbClr val="FFFFFF"/>
-                </a:solidFill>
-                <a:latin typeface="Montserrat"/>
-                <a:ea typeface="Montserrat"/>
-                <a:cs typeface="Montserrat"/>
-              </a:rPr>
-              <a:t>02  WORKER</a:t>
-            </a:r>
-            <a:br>
-              <a:rPr sz="1575" b="1">
-                <a:solidFill>
-                  <a:srgbClr val="FFFFFF"/>
-                </a:solidFill>
-                <a:latin typeface="Montserrat"/>
-                <a:ea typeface="Montserrat"/>
-                <a:cs typeface="Montserrat"/>
-              </a:rPr>
-            </a:br>
-            <a:r>
-              <a:rPr sz="1575" b="1">
-                <a:solidFill>
-                  <a:srgbClr val="FFFFFF"/>
-                </a:solidFill>
-                <a:latin typeface="Montserrat"/>
-                <a:ea typeface="Montserrat"/>
-                <a:cs typeface="Montserrat"/>
-              </a:rPr>
-              <a:t>Claims one tranche per period.</a:t>
-            </a:r>
-          </a:p>
-          <a:p xmlns:a="http://schemas.openxmlformats.org/drawingml/2006/main">
-            <a:pPr marL="0" indent="0" algn="l">
-              <a:lnSpc>
-                <a:spcPct val="108000"/>
-              </a:lnSpc>
-              <a:spcAft>
-                <a:spcPts val="14"/>
-              </a:spcAft>
-              <a:buNone/>
-              <a:defRPr sz="1575" b="1">
-                <a:solidFill>
-                  <a:srgbClr val="FFFFFF"/>
-                </a:solidFill>
-                <a:latin typeface="Montserrat"/>
-                <a:ea typeface="Montserrat"/>
-                <a:cs typeface="Montserrat"/>
-              </a:defRPr>
-            </a:pPr>
-            <a:r>
-              <a:rPr sz="1575" b="1">
-                <a:solidFill>
-                  <a:srgbClr val="FFFFFF"/>
-                </a:solidFill>
-                <a:latin typeface="Montserrat"/>
-                <a:ea typeface="Montserrat"/>
-                <a:cs typeface="Montserrat"/>
-              </a:rPr>
-              <a:t>03  AGENT</a:t>
-            </a:r>
-            <a:br>
-              <a:rPr sz="1575" b="1">
-                <a:solidFill>
-                  <a:srgbClr val="FFFFFF"/>
-                </a:solidFill>
-                <a:latin typeface="Montserrat"/>
-                <a:ea typeface="Montserrat"/>
-                <a:cs typeface="Montserrat"/>
-              </a:rPr>
-            </a:br>
-            <a:r>
-              <a:rPr sz="1575" b="1">
-                <a:solidFill>
-                  <a:srgbClr val="FFFFFF"/>
-                </a:solidFill>
-                <a:latin typeface="Montserrat"/>
-                <a:ea typeface="Montserrat"/>
-                <a:cs typeface="Montserrat"/>
-              </a:rPr>
-              <a:t>Pays a service per request.</a:t>
-            </a:r>
-          </a:p>
-          <a:p xmlns:a="http://schemas.openxmlformats.org/drawingml/2006/main">
-            <a:pPr marL="0" indent="0" algn="l">
-              <a:lnSpc>
-                <a:spcPct val="108000"/>
-              </a:lnSpc>
-              <a:spcAft>
-                <a:spcPts val="0"/>
-              </a:spcAft>
-              <a:buNone/>
-              <a:defRPr sz="1575" b="1">
-                <a:solidFill>
-                  <a:srgbClr val="FFFFFF"/>
-                </a:solidFill>
-                <a:latin typeface="Montserrat"/>
-                <a:ea typeface="Montserrat"/>
-                <a:cs typeface="Montserrat"/>
-              </a:defRPr>
-            </a:pPr>
-            <a:r>
-              <a:rPr sz="1575" b="1">
-                <a:solidFill>
-                  <a:srgbClr val="FFFFFF"/>
-                </a:solidFill>
-                <a:latin typeface="Montserrat"/>
-                <a:ea typeface="Montserrat"/>
-                <a:cs typeface="Montserrat"/>
-              </a:rPr>
-              <a:t>Shared rules: claim(), cancel(), amountPerPeriod, periodBlocks.</a:t>
-            </a:r>
-          </a:p>
+          <ns0:p xmlns:ns0="http://schemas.openxmlformats.org/drawingml/2006/main">
+            <ns0:pPr marL="0" indent="0" algn="l">
+              <ns0:lnSpc>
+                <ns0:spcPct val="108000"/>
+              </ns0:lnSpc>
+              <ns0:spcAft>
+                <ns0:spcPts val="1400"/>
+              </ns0:spcAft>
+              <ns0:buNone/>
+              <ns0:defRPr sz="1575" b="1">
+                <ns0:solidFill>
+                  <ns0:srgbClr val="FFFFFF"/>
+                </ns0:solidFill>
+                <ns0:latin typeface="Montserrat"/>
+                <ns0:ea typeface="Montserrat"/>
+                <ns0:cs typeface="Montserrat"/>
+              </ns0:defRPr>
+            </ns0:pPr>
+            <ns0:r>
+              <ns0:rPr sz="1050">
+                <ns0:solidFill>
+                  <ns0:srgbClr val="D08C98"/>
+                </ns0:solidFill>
+              </ns0:rPr>
+              <ns0:t>01  SPONSOR</ns0:t>
+            </ns0:r>
+            <ns0:br/>
+            <ns0:r>
+              <ns0:rPr sz="1575">
+                <ns0:solidFill>
+                  <ns0:srgbClr val="FFFFFF"/>
+                </ns0:solidFill>
+              </ns0:rPr>
+              <ns0:t>Locks PUSD. Keeps cancel control.</ns0:t>
+            </ns0:r>
+          </ns0:p>
+          <ns6:p xmlns:ns6="http://schemas.openxmlformats.org/drawingml/2006/main">
+            <ns6:pPr marL="0" indent="0" algn="l">
+              <ns6:lnSpc>
+                <ns6:spcPct val="108000"/>
+              </ns6:lnSpc>
+              <ns6:spcAft>
+                <ns6:spcPts val="1400"/>
+              </ns6:spcAft>
+              <ns6:buNone/>
+              <ns6:defRPr sz="1575" b="1">
+                <ns6:solidFill>
+                  <ns6:srgbClr val="FFFFFF"/>
+                </ns6:solidFill>
+                <ns6:latin typeface="Montserrat"/>
+                <ns6:ea typeface="Montserrat"/>
+                <ns6:cs typeface="Montserrat"/>
+              </ns6:defRPr>
+            </ns6:pPr>
+            <ns6:r>
+              <ns6:rPr sz="1050">
+                <ns6:solidFill>
+                  <ns6:srgbClr val="D08C98"/>
+                </ns6:solidFill>
+              </ns6:rPr>
+              <ns6:t>02  WORKER</ns6:t>
+            </ns6:r>
+            <ns6:br/>
+            <ns6:r>
+              <ns6:rPr sz="1575">
+                <ns6:solidFill>
+                  <ns6:srgbClr val="FFFFFF"/>
+                </ns6:solidFill>
+              </ns6:rPr>
+              <ns6:t>Claims one tranche per period.</ns6:t>
+            </ns6:r>
+          </ns6:p>
+          <ns12:p xmlns:ns12="http://schemas.openxmlformats.org/drawingml/2006/main">
+            <ns12:pPr marL="0" indent="0" algn="l">
+              <ns12:lnSpc>
+                <ns12:spcPct val="108000"/>
+              </ns12:lnSpc>
+              <ns12:spcAft>
+                <ns12:spcPts val="1400"/>
+              </ns12:spcAft>
+              <ns12:buNone/>
+              <ns12:defRPr sz="1575" b="1">
+                <ns12:solidFill>
+                  <ns12:srgbClr val="FFFFFF"/>
+                </ns12:solidFill>
+                <ns12:latin typeface="Montserrat"/>
+                <ns12:ea typeface="Montserrat"/>
+                <ns12:cs typeface="Montserrat"/>
+              </ns12:defRPr>
+            </ns12:pPr>
+            <ns12:r>
+              <ns12:rPr sz="1050">
+                <ns12:solidFill>
+                  <ns12:srgbClr val="D08C98"/>
+                </ns12:solidFill>
+              </ns12:rPr>
+              <ns12:t>03  AGENT</ns12:t>
+            </ns12:r>
+            <ns12:br/>
+            <ns12:r>
+              <ns12:rPr sz="1575">
+                <ns12:solidFill>
+                  <ns12:srgbClr val="FFFFFF"/>
+                </ns12:solidFill>
+              </ns12:rPr>
+              <ns12:t>Pays a service per request.</ns12:t>
+            </ns12:r>
+          </ns12:p>
+          <ns18:p xmlns:ns18="http://schemas.openxmlformats.org/drawingml/2006/main">
+            <ns18:pPr marL="0" indent="0" algn="l">
+              <ns18:lnSpc>
+                <ns18:spcPct val="108000"/>
+              </ns18:lnSpc>
+              <ns18:spcAft>
+                <ns18:spcPts val="0"/>
+              </ns18:spcAft>
+              <ns18:buNone/>
+              <ns18:defRPr sz="1575" b="1">
+                <ns18:solidFill>
+                  <ns18:srgbClr val="FFFFFF"/>
+                </ns18:solidFill>
+                <ns18:latin typeface="Montserrat"/>
+                <ns18:ea typeface="Montserrat"/>
+                <ns18:cs typeface="Montserrat"/>
+              </ns18:defRPr>
+            </ns18:pPr>
+            <ns18:r>
+              <ns18:rPr sz="1200">
+                <ns18:solidFill>
+                  <ns18:srgbClr val="8AE6C6"/>
+                </ns18:solidFill>
+              </ns18:rPr>
+              <ns18:t>Shared rules: claim(), cancel(), amountPerPeriod, periodBlocks.</ns18:t>
+            </ns18:r>
+          </ns18:p>
         </p:txBody>
       </p:sp>
       <p:pic>
@@ -11612,6 +11554,277 @@
           </a:ln>
         </p:spPr>
       </p:pic>
+      <p:sp>
+        <p:nvSpPr>
+          <p:cNvPr id="110" name="covenant-stats"/>
+          <p:cNvSpPr>
+            <a:spLocks xmlns:a="http://schemas.openxmlformats.org/drawingml/2006/main" noGrp="1"/>
+          </p:cNvSpPr>
+          <p:nvPr/>
+        </p:nvSpPr>
+        <p:spPr>
+          <a:xfrm xmlns:a="http://schemas.openxmlformats.org/drawingml/2006/main">
+            <a:off x="786384" y="2852928"/>
+            <a:ext cx="2514600" cy="1600200"/>
+          </a:xfrm>
+          <a:prstGeom xmlns:a="http://schemas.openxmlformats.org/drawingml/2006/main" prst="rect">
+            <a:avLst/>
+          </a:prstGeom>
+          <a:noFill xmlns:a="http://schemas.openxmlformats.org/drawingml/2006/main"/>
+          <a:ln xmlns:a="http://schemas.openxmlformats.org/drawingml/2006/main">
+            <a:noFill/>
+          </a:ln>
+        </p:spPr>
+        <p:txBody>
+          <a:bodyPr xmlns:a="http://schemas.openxmlformats.org/drawingml/2006/main" spcFirstLastPara="1" wrap="square" lIns="91425" tIns="91425" rIns="91425" bIns="91425" anchor="t">
+            <a:noAutofit/>
+          </a:bodyPr>
+          <a:lstStyle xmlns:a="http://schemas.openxmlformats.org/drawingml/2006/main">
+            <a:defPPr algn="l">
+              <a:defRPr sz="2550" b="1">
+                <a:solidFill>
+                  <a:srgbClr val="FFFFFF"/>
+                </a:solidFill>
+                <a:latin typeface="Roboto"/>
+                <a:ea typeface="Roboto"/>
+                <a:cs typeface="Roboto"/>
+              </a:defRPr>
+            </a:defPPr>
+            <a:lvl1pPr algn="l">
+              <a:defRPr sz="2550" b="1">
+                <a:solidFill>
+                  <a:srgbClr val="FFFFFF"/>
+                </a:solidFill>
+                <a:latin typeface="Roboto"/>
+                <a:ea typeface="Roboto"/>
+                <a:cs typeface="Roboto"/>
+              </a:defRPr>
+            </a:lvl1pPr>
+            <a:lvl2pPr algn="l">
+              <a:defRPr sz="2550" b="1">
+                <a:solidFill>
+                  <a:srgbClr val="FFFFFF"/>
+                </a:solidFill>
+                <a:latin typeface="Roboto"/>
+                <a:ea typeface="Roboto"/>
+                <a:cs typeface="Roboto"/>
+              </a:defRPr>
+            </a:lvl2pPr>
+            <a:lvl3pPr algn="l">
+              <a:defRPr sz="2550" b="1">
+                <a:solidFill>
+                  <a:srgbClr val="FFFFFF"/>
+                </a:solidFill>
+                <a:latin typeface="Roboto"/>
+                <a:ea typeface="Roboto"/>
+                <a:cs typeface="Roboto"/>
+              </a:defRPr>
+            </a:lvl3pPr>
+            <a:lvl4pPr algn="l">
+              <a:defRPr sz="2550" b="1">
+                <a:solidFill>
+                  <a:srgbClr val="FFFFFF"/>
+                </a:solidFill>
+                <a:latin typeface="Roboto"/>
+                <a:ea typeface="Roboto"/>
+                <a:cs typeface="Roboto"/>
+              </a:defRPr>
+            </a:lvl4pPr>
+            <a:lvl5pPr algn="l">
+              <a:defRPr sz="2550" b="1">
+                <a:solidFill>
+                  <a:srgbClr val="FFFFFF"/>
+                </a:solidFill>
+                <a:latin typeface="Roboto"/>
+                <a:ea typeface="Roboto"/>
+                <a:cs typeface="Roboto"/>
+              </a:defRPr>
+            </a:lvl5pPr>
+            <a:lvl6pPr algn="l">
+              <a:defRPr sz="2550" b="1">
+                <a:solidFill>
+                  <a:srgbClr val="FFFFFF"/>
+                </a:solidFill>
+                <a:latin typeface="Roboto"/>
+                <a:ea typeface="Roboto"/>
+                <a:cs typeface="Roboto"/>
+              </a:defRPr>
+            </a:lvl6pPr>
+            <a:lvl7pPr algn="l">
+              <a:defRPr sz="2550" b="1">
+                <a:solidFill>
+                  <a:srgbClr val="FFFFFF"/>
+                </a:solidFill>
+                <a:latin typeface="Roboto"/>
+                <a:ea typeface="Roboto"/>
+                <a:cs typeface="Roboto"/>
+              </a:defRPr>
+            </a:lvl7pPr>
+            <a:lvl8pPr algn="l">
+              <a:defRPr sz="2550" b="1">
+                <a:solidFill>
+                  <a:srgbClr val="FFFFFF"/>
+                </a:solidFill>
+                <a:latin typeface="Roboto"/>
+                <a:ea typeface="Roboto"/>
+                <a:cs typeface="Roboto"/>
+              </a:defRPr>
+            </a:lvl8pPr>
+            <a:lvl9pPr algn="l">
+              <a:defRPr sz="2550" b="1">
+                <a:solidFill>
+                  <a:srgbClr val="FFFFFF"/>
+                </a:solidFill>
+                <a:latin typeface="Roboto"/>
+                <a:ea typeface="Roboto"/>
+                <a:cs typeface="Roboto"/>
+              </a:defRPr>
+            </a:lvl9pPr>
+          </a:lstStyle>
+          <ns21:p xmlns:ns21="http://schemas.openxmlformats.org/drawingml/2006/main">
+            <ns21:pPr marL="0" lvl="0" indent="0" algn="l">
+              <ns21:spcBef>
+                <ns21:spcPts val="0"/>
+              </ns21:spcBef>
+              <ns21:spcAft>
+                <ns21:spcPts val="200"/>
+              </ns21:spcAft>
+              <ns21:buNone/>
+              <ns21:defRPr sz="2550" b="1">
+                <ns21:solidFill>
+                  <ns21:srgbClr val="FFFFFF"/>
+                </ns21:solidFill>
+                <ns21:latin typeface="Roboto"/>
+                <ns21:ea typeface="Roboto"/>
+                <ns21:cs typeface="Roboto"/>
+              </ns21:defRPr>
+            </ns21:pPr>
+            <ns21:r>
+              <ns21:rPr sz="3000" b="1">
+                <ns21:solidFill>
+                  <ns21:srgbClr val="FFFFFF"/>
+                </ns21:solidFill>
+                <ns21:latin typeface="Roboto"/>
+                <ns21:ea typeface="Roboto"/>
+                <ns21:cs typeface="Roboto"/>
+              </ns21:rPr>
+              <ns21:t>3</ns21:t>
+            </ns21:r>
+            <ns21:r>
+              <ns21:rPr sz="1300" b="1">
+                <ns21:solidFill>
+                  <ns21:srgbClr val="FFFFFF"/>
+                </ns21:solidFill>
+                <ns21:latin typeface="Roboto"/>
+                <ns21:ea typeface="Roboto"/>
+                <ns21:cs typeface="Roboto"/>
+              </ns21:rPr>
+              <ns21:t>  spend paths</ns21:t>
+            </ns21:r>
+          </ns21:p>
+          <ns32:p xmlns:ns32="http://schemas.openxmlformats.org/drawingml/2006/main">
+            <ns32:pPr marL="0" lvl="0" indent="0" algn="l">
+              <ns32:spcBef>
+                <ns32:spcPts val="0"/>
+              </ns32:spcBef>
+              <ns32:spcAft>
+                <ns32:spcPts val="1200"/>
+              </ns32:spcAft>
+              <ns32:buNone/>
+              <ns32:defRPr sz="2550" b="1">
+                <ns32:solidFill>
+                  <ns32:srgbClr val="FFFFFF"/>
+                </ns32:solidFill>
+                <ns32:latin typeface="Roboto"/>
+                <ns32:ea typeface="Roboto"/>
+                <ns32:cs typeface="Roboto"/>
+              </ns32:defRPr>
+            </ns32:pPr>
+            <ns32:r>
+              <ns32:rPr sz="1000" b="1">
+                <ns32:solidFill>
+                  <ns32:srgbClr val="D08C98"/>
+                </ns32:solidFill>
+                <ns32:latin typeface="Montserrat"/>
+                <ns32:ea typeface="Montserrat"/>
+                <ns32:cs typeface="Montserrat"/>
+              </ns32:rPr>
+              <ns32:t>claim · topUp · cancel</ns32:t>
+            </ns32:r>
+          </ns32:p>
+          <ns38:p xmlns:ns38="http://schemas.openxmlformats.org/drawingml/2006/main">
+            <ns38:pPr marL="0" lvl="0" indent="0" algn="l">
+              <ns38:spcBef>
+                <ns38:spcPts val="0"/>
+              </ns38:spcBef>
+              <ns38:spcAft>
+                <ns38:spcPts val="200"/>
+              </ns38:spcAft>
+              <ns38:buNone/>
+              <ns38:defRPr sz="2550" b="1">
+                <ns38:solidFill>
+                  <ns38:srgbClr val="FFFFFF"/>
+                </ns38:solidFill>
+                <ns38:latin typeface="Roboto"/>
+                <ns38:ea typeface="Roboto"/>
+                <ns38:cs typeface="Roboto"/>
+              </ns38:defRPr>
+            </ns38:pPr>
+            <ns38:r>
+              <ns38:rPr sz="3000" b="1">
+                <ns38:solidFill>
+                  <ns38:srgbClr val="FFFFFF"/>
+                </ns38:solidFill>
+                <ns38:latin typeface="Roboto"/>
+                <ns38:ea typeface="Roboto"/>
+                <ns38:cs typeface="Roboto"/>
+              </ns38:rPr>
+              <ns38:t>21</ns38:t>
+            </ns38:r>
+            <ns38:r>
+              <ns38:rPr sz="1300" b="1">
+                <ns38:solidFill>
+                  <ns38:srgbClr val="FFFFFF"/>
+                </ns38:solidFill>
+                <ns38:latin typeface="Roboto"/>
+                <ns38:ea typeface="Roboto"/>
+                <ns38:cs typeface="Roboto"/>
+              </ns38:rPr>
+              <ns38:t>  VM tests</ns38:t>
+            </ns38:r>
+          </ns38:p>
+          <ns49:p xmlns:ns49="http://schemas.openxmlformats.org/drawingml/2006/main">
+            <ns49:pPr marL="0" lvl="0" indent="0" algn="l">
+              <ns49:spcBef>
+                <ns49:spcPts val="0"/>
+              </ns49:spcBef>
+              <ns49:spcAft>
+                <ns49:spcPts val="200"/>
+              </ns49:spcAft>
+              <ns49:buNone/>
+              <ns49:defRPr sz="2550" b="1">
+                <ns49:solidFill>
+                  <ns49:srgbClr val="FFFFFF"/>
+                </ns49:solidFill>
+                <ns49:latin typeface="Roboto"/>
+                <ns49:ea typeface="Roboto"/>
+                <ns49:cs typeface="Roboto"/>
+              </ns49:defRPr>
+            </ns49:pPr>
+            <ns49:r>
+              <ns49:rPr sz="1000" b="1">
+                <ns49:solidFill>
+                  <ns49:srgbClr val="D08C98"/>
+                </ns49:solidFill>
+                <ns49:latin typeface="Montserrat"/>
+                <ns49:ea typeface="Montserrat"/>
+                <ns49:cs typeface="Montserrat"/>
+              </ns49:rPr>
+              <ns49:t>run against the real BCH VM</ns49:t>
+            </ns49:r>
+          </ns49:p>
+        </p:txBody>
+      </p:sp>
     </p:spTree>
     <p:extLst>
       <p:ext uri="{BB962C8B-B14F-4D97-AF65-F5344CB8AC3E}">
@@ -12523,8 +12736,8 @@
         </p:nvSpPr>
         <p:spPr>
           <a:xfrm xmlns:a="http://schemas.openxmlformats.org/drawingml/2006/main">
-            <a:off x="6334125" y="1381125"/>
-            <a:ext cx="2143125" cy="904875"/>
+            <a:off x="6336792" y="1381125"/>
+            <a:ext cx="2304288" cy="904875"/>
           </a:xfrm>
           <a:prstGeom xmlns:a="http://schemas.openxmlformats.org/drawingml/2006/main" prst="rect">
             <a:avLst/>
@@ -12659,7 +12872,7 @@
               </a:defRPr>
             </a:pPr>
             <a:r>
-              <a:rPr sz="1275" b="1">
+              <a:rPr sz="1200" b="1">
                 <a:solidFill>
                   <a:srgbClr val="FFFFFF"/>
                 </a:solidFill>
@@ -12672,6 +12885,7 @@
           </a:p>
           <a:p xmlns:a="http://schemas.openxmlformats.org/drawingml/2006/main">
             <a:r>
+              <a:rPr sz="1200"/>
               <a:t/>
             </a:r>
           </a:p>
@@ -12691,7 +12905,7 @@
               </a:defRPr>
             </a:pPr>
             <a:r>
-              <a:rPr sz="1275" b="1">
+              <a:rPr sz="1200" b="1">
                 <a:solidFill>
                   <a:srgbClr val="FFFFFF"/>
                 </a:solidFill>
@@ -12718,7 +12932,7 @@
               </a:defRPr>
             </a:pPr>
             <a:r>
-              <a:rPr sz="1275" b="1">
+              <a:rPr sz="1200" b="1">
                 <a:solidFill>
                   <a:srgbClr val="FFFFFF"/>
                 </a:solidFill>
@@ -12747,8 +12961,8 @@
         </p:nvSpPr>
         <p:spPr>
           <a:xfrm xmlns:a="http://schemas.openxmlformats.org/drawingml/2006/main">
-            <a:off x="6334125" y="2667000"/>
-            <a:ext cx="2143125" cy="904875"/>
+            <a:off x="6336792" y="2667000"/>
+            <a:ext cx="2304288" cy="904875"/>
           </a:xfrm>
           <a:prstGeom xmlns:a="http://schemas.openxmlformats.org/drawingml/2006/main" prst="rect">
             <a:avLst/>
@@ -12883,7 +13097,7 @@
               </a:defRPr>
             </a:pPr>
             <a:r>
-              <a:rPr sz="1275" b="1">
+              <a:rPr sz="1200" b="1">
                 <a:solidFill>
                   <a:srgbClr val="FFFFFF"/>
                 </a:solidFill>
@@ -12896,6 +13110,7 @@
           </a:p>
           <a:p xmlns:a="http://schemas.openxmlformats.org/drawingml/2006/main">
             <a:r>
+              <a:rPr sz="1200"/>
               <a:t/>
             </a:r>
           </a:p>
@@ -12915,7 +13130,7 @@
               </a:defRPr>
             </a:pPr>
             <a:r>
-              <a:rPr sz="1275" b="1">
+              <a:rPr sz="1200" b="1">
                 <a:solidFill>
                   <a:srgbClr val="FFFFFF"/>
                 </a:solidFill>
@@ -12942,7 +13157,7 @@
               </a:defRPr>
             </a:pPr>
             <a:r>
-              <a:rPr sz="1275" b="1">
+              <a:rPr sz="1200" b="1">
                 <a:solidFill>
                   <a:srgbClr val="FFFFFF"/>
                 </a:solidFill>
@@ -13002,8 +13217,8 @@
         </p:nvSpPr>
         <p:spPr>
           <a:xfrm xmlns:a="http://schemas.openxmlformats.org/drawingml/2006/main">
-            <a:off x="857250" y="4000500"/>
-            <a:ext cx="3524250" cy="609600"/>
+            <a:off x="859536" y="4005072"/>
+            <a:ext cx="4069080" cy="612648"/>
           </a:xfrm>
           <a:prstGeom xmlns:a="http://schemas.openxmlformats.org/drawingml/2006/main" prst="rect">
             <a:avLst/>
@@ -13190,8 +13405,8 @@
         </p:nvSpPr>
         <p:spPr>
           <a:xfrm xmlns:a="http://schemas.openxmlformats.org/drawingml/2006/main">
-            <a:off x="4762500" y="4114800"/>
-            <a:ext cx="3714750" cy="323850"/>
+            <a:off x="5074920" y="4114800"/>
+            <a:ext cx="3401568" cy="320040"/>
           </a:xfrm>
           <a:prstGeom xmlns:a="http://schemas.openxmlformats.org/drawingml/2006/main" prst="rect">
             <a:avLst/>
@@ -13668,44 +13883,66 @@
               </a:defRPr>
             </a:lvl9pPr>
           </a:lstStyle>
-          <a:p xmlns:a="http://schemas.openxmlformats.org/drawingml/2006/main">
-            <a:pPr marL="0" lvl="0" indent="0" algn="l">
-              <a:spcBef>
-                <a:spcPts val="0"/>
-              </a:spcBef>
-              <a:spcAft>
-                <a:spcPts val="0"/>
-              </a:spcAft>
-              <a:buNone/>
-              <a:defRPr sz="3300" b="1">
-                <a:solidFill>
-                  <a:srgbClr val="FFFFFF"/>
-                </a:solidFill>
-                <a:latin typeface="Roboto"/>
-                <a:ea typeface="Roboto"/>
-                <a:cs typeface="Roboto"/>
-              </a:defRPr>
-            </a:pPr>
-            <a:r>
-              <a:rPr sz="3300" b="1">
-                <a:solidFill>
-                  <a:srgbClr val="FFFFFF"/>
-                </a:solidFill>
-                <a:latin typeface="Roboto"/>
-                <a:ea typeface="Roboto"/>
-                <a:cs typeface="Roboto"/>
-              </a:rPr>
-              <a:t>Why BCH</a:t>
-            </a:r>
-            <a:endParaRPr sz="2900" b="1">
-              <a:solidFill>
-                <a:schemeClr val="lt1"/>
-              </a:solidFill>
-              <a:latin typeface="Roboto"/>
-              <a:ea typeface="Roboto"/>
-              <a:cs typeface="Roboto"/>
-            </a:endParaRPr>
-          </a:p>
+          <ns0:p xmlns:ns0="http://schemas.openxmlformats.org/drawingml/2006/main">
+            <ns0:pPr marL="0" lvl="0" indent="0" algn="l">
+              <ns0:spcBef>
+                <ns0:spcPts val="0"/>
+              </ns0:spcBef>
+              <ns0:spcAft>
+                <ns0:spcPts val="0"/>
+              </ns0:spcAft>
+              <ns0:buNone/>
+              <ns0:defRPr sz="3300" b="1">
+                <ns0:solidFill>
+                  <ns0:srgbClr val="FFFFFF"/>
+                </ns0:solidFill>
+                <ns0:latin typeface="Roboto"/>
+                <ns0:ea typeface="Roboto"/>
+                <ns0:cs typeface="Roboto"/>
+              </ns0:defRPr>
+            </ns0:pPr>
+            <ns0:r>
+              <ns0:rPr sz="3300" b="1">
+                <ns0:solidFill>
+                  <ns0:srgbClr val="FFFFFF"/>
+                </ns0:solidFill>
+                <ns0:latin typeface="Roboto"/>
+                <ns0:ea typeface="Roboto"/>
+                <ns0:cs typeface="Roboto"/>
+              </ns0:rPr>
+              <ns0:t>Why BCH,</ns0:t>
+            </ns0:r>
+          </ns0:p>
+          <ns6:p xmlns:ns6="http://schemas.openxmlformats.org/drawingml/2006/main">
+            <ns6:pPr marL="0" lvl="0" indent="0" algn="l">
+              <ns6:spcBef>
+                <ns6:spcPts val="0"/>
+              </ns6:spcBef>
+              <ns6:spcAft>
+                <ns6:spcPts val="0"/>
+              </ns6:spcAft>
+              <ns6:buNone/>
+              <ns6:defRPr sz="3300" b="1">
+                <ns6:solidFill>
+                  <ns6:srgbClr val="FFFFFF"/>
+                </ns6:solidFill>
+                <ns6:latin typeface="Roboto"/>
+                <ns6:ea typeface="Roboto"/>
+                <ns6:cs typeface="Roboto"/>
+              </ns6:defRPr>
+            </ns6:pPr>
+            <ns6:r>
+              <ns6:rPr sz="3300" b="1">
+                <ns6:solidFill>
+                  <ns6:srgbClr val="FFFFFF"/>
+                </ns6:solidFill>
+                <ns6:latin typeface="Roboto"/>
+                <ns6:ea typeface="Roboto"/>
+                <ns6:cs typeface="Roboto"/>
+              </ns6:rPr>
+              <ns6:t>who pays</ns6:t>
+            </ns6:r>
+          </ns6:p>
         </p:txBody>
       </p:sp>
       <p:sp>
@@ -13724,8 +13961,8 @@
         </p:nvSpPr>
         <p:spPr>
           <a:xfrm xmlns:a="http://schemas.openxmlformats.org/drawingml/2006/main">
-            <a:off x="3714750" y="523875"/>
-            <a:ext cx="38100" cy="1666875"/>
+            <a:off x="3712463" y="521207"/>
+            <a:ext cx="38100" cy="1417320"/>
           </a:xfrm>
           <a:prstGeom xmlns:a="http://schemas.openxmlformats.org/drawingml/2006/main" prst="rect">
             <a:avLst/>
@@ -13755,7 +13992,7 @@
         </p:nvSpPr>
         <p:spPr>
           <a:xfrm xmlns:a="http://schemas.openxmlformats.org/drawingml/2006/main">
-            <a:off x="3952875" y="523875"/>
+            <a:off x="3950208" y="521207"/>
             <a:ext cx="2095500" cy="228600"/>
           </a:xfrm>
           <a:prstGeom xmlns:a="http://schemas.openxmlformats.org/drawingml/2006/main" prst="rect">
@@ -13916,8 +14153,8 @@
         </p:nvSpPr>
         <p:spPr>
           <a:xfrm xmlns:a="http://schemas.openxmlformats.org/drawingml/2006/main">
-            <a:off x="3952875" y="838200"/>
-            <a:ext cx="4095750" cy="1524000"/>
+            <a:off x="3950208" y="786384"/>
+            <a:ext cx="4480560" cy="1188720"/>
           </a:xfrm>
           <a:prstGeom xmlns:a="http://schemas.openxmlformats.org/drawingml/2006/main" prst="rect">
             <a:avLst/>
@@ -14032,114 +14269,86 @@
               </a:defRPr>
             </a:lvl9pPr>
           </a:lstStyle>
-          <a:p xmlns:a="http://schemas.openxmlformats.org/drawingml/2006/main">
-            <a:pPr algn="l">
-              <a:lnSpc>
-                <a:spcPct val="114000"/>
-              </a:lnSpc>
-              <a:buNone/>
-              <a:defRPr sz="1275" b="1">
-                <a:solidFill>
-                  <a:srgbClr val="FFFFFF"/>
-                </a:solidFill>
-                <a:latin typeface="Montserrat"/>
-                <a:ea typeface="Montserrat"/>
-                <a:cs typeface="Montserrat"/>
-              </a:defRPr>
-            </a:pPr>
-            <a:r>
-              <a:rPr sz="1275" b="1">
-                <a:solidFill>
-                  <a:srgbClr val="FFFFFF"/>
-                </a:solidFill>
-                <a:latin typeface="Montserrat"/>
-                <a:ea typeface="Montserrat"/>
-                <a:cs typeface="Montserrat"/>
-              </a:rPr>
-              <a:t>01  Sub-cent settlement makes $0.01 calls practical</a:t>
-            </a:r>
-          </a:p>
-          <a:p xmlns:a="http://schemas.openxmlformats.org/drawingml/2006/main">
-            <a:pPr algn="l">
-              <a:lnSpc>
-                <a:spcPct val="114000"/>
-              </a:lnSpc>
-              <a:buNone/>
-              <a:defRPr sz="1275" b="1">
-                <a:solidFill>
-                  <a:srgbClr val="FFFFFF"/>
-                </a:solidFill>
-                <a:latin typeface="Montserrat"/>
-                <a:ea typeface="Montserrat"/>
-                <a:cs typeface="Montserrat"/>
-              </a:defRPr>
-            </a:pPr>
-            <a:r>
-              <a:rPr sz="1275" b="1">
-                <a:solidFill>
-                  <a:srgbClr val="FFFFFF"/>
-                </a:solidFill>
-                <a:latin typeface="Montserrat"/>
-                <a:ea typeface="Montserrat"/>
-                <a:cs typeface="Montserrat"/>
-              </a:rPr>
-              <a:t>02  CashTokens conserve PUSD on chain</a:t>
-            </a:r>
-          </a:p>
-          <a:p xmlns:a="http://schemas.openxmlformats.org/drawingml/2006/main">
-            <a:pPr algn="l">
-              <a:lnSpc>
-                <a:spcPct val="114000"/>
-              </a:lnSpc>
-              <a:buNone/>
-              <a:defRPr sz="1275" b="1">
-                <a:solidFill>
-                  <a:srgbClr val="FFFFFF"/>
-                </a:solidFill>
-                <a:latin typeface="Montserrat"/>
-                <a:ea typeface="Montserrat"/>
-                <a:cs typeface="Montserrat"/>
-              </a:defRPr>
-            </a:pPr>
-            <a:r>
-              <a:rPr sz="1275" b="1">
-                <a:solidFill>
-                  <a:srgbClr val="FFFFFF"/>
-                </a:solidFill>
-                <a:latin typeface="Montserrat"/>
-                <a:ea typeface="Montserrat"/>
-                <a:cs typeface="Montserrat"/>
-              </a:rPr>
-              <a:t>03  Relative timelocks enforce the period</a:t>
-            </a:r>
-          </a:p>
-          <a:p xmlns:a="http://schemas.openxmlformats.org/drawingml/2006/main">
-            <a:pPr algn="l">
-              <a:lnSpc>
-                <a:spcPct val="114000"/>
-              </a:lnSpc>
-              <a:buNone/>
-              <a:defRPr sz="1275" b="1">
-                <a:solidFill>
-                  <a:srgbClr val="FFFFFF"/>
-                </a:solidFill>
-                <a:latin typeface="Montserrat"/>
-                <a:ea typeface="Montserrat"/>
-                <a:cs typeface="Montserrat"/>
-              </a:defRPr>
-            </a:pPr>
-            <a:r>
-              <a:rPr sz="1275" b="1">
-                <a:solidFill>
-                  <a:srgbClr val="FFFFFF"/>
-                </a:solidFill>
-                <a:latin typeface="Montserrat"/>
-                <a:ea typeface="Montserrat"/>
-                <a:cs typeface="Montserrat"/>
-              </a:rPr>
-              <a:t>04  WizardConnect keeps keys in the wallet</a:t>
-            </a:r>
-          </a:p>
+          <ns12:p xmlns:ns12="http://schemas.openxmlformats.org/drawingml/2006/main">
+            <ns12:pPr algn="l">
+              <ns12:lnSpc>
+                <ns12:spcPct val="114000"/>
+              </ns12:lnSpc>
+              <ns12:buNone/>
+              <ns12:defRPr sz="1275" b="1">
+                <ns12:solidFill>
+                  <ns12:srgbClr val="FFFFFF"/>
+                </ns12:solidFill>
+                <ns12:latin typeface="Montserrat"/>
+                <ns12:ea typeface="Montserrat"/>
+                <ns12:cs typeface="Montserrat"/>
+              </ns12:defRPr>
+            </ns12:pPr>
+            <ns12:r>
+              <ns12:rPr sz="1200"/>
+              <ns12:t>01  Sub-cent fees make $0.01 calls viable</ns12:t>
+            </ns12:r>
+          </ns12:p>
+          <ns13:p xmlns:ns13="http://schemas.openxmlformats.org/drawingml/2006/main">
+            <ns13:pPr algn="l">
+              <ns13:lnSpc>
+                <ns13:spcPct val="114000"/>
+              </ns13:lnSpc>
+              <ns13:buNone/>
+              <ns13:defRPr sz="1275" b="1">
+                <ns13:solidFill>
+                  <ns13:srgbClr val="FFFFFF"/>
+                </ns13:solidFill>
+                <ns13:latin typeface="Montserrat"/>
+                <ns13:ea typeface="Montserrat"/>
+                <ns13:cs typeface="Montserrat"/>
+              </ns13:defRPr>
+            </ns13:pPr>
+            <ns13:r>
+              <ns13:rPr sz="1200"/>
+              <ns13:t>02  CashTokens conserve PUSD on chain</ns13:t>
+            </ns13:r>
+          </ns13:p>
+          <ns14:p xmlns:ns14="http://schemas.openxmlformats.org/drawingml/2006/main">
+            <ns14:pPr algn="l">
+              <ns14:lnSpc>
+                <ns14:spcPct val="114000"/>
+              </ns14:lnSpc>
+              <ns14:buNone/>
+              <ns14:defRPr sz="1275" b="1">
+                <ns14:solidFill>
+                  <ns14:srgbClr val="FFFFFF"/>
+                </ns14:solidFill>
+                <ns14:latin typeface="Montserrat"/>
+                <ns14:ea typeface="Montserrat"/>
+                <ns14:cs typeface="Montserrat"/>
+              </ns14:defRPr>
+            </ns14:pPr>
+            <ns14:r>
+              <ns14:rPr sz="1200"/>
+              <ns14:t>03  Relative timelocks enforce the period</ns14:t>
+            </ns14:r>
+          </ns14:p>
+          <ns15:p xmlns:ns15="http://schemas.openxmlformats.org/drawingml/2006/main">
+            <ns15:pPr algn="l">
+              <ns15:lnSpc>
+                <ns15:spcPct val="114000"/>
+              </ns15:lnSpc>
+              <ns15:buNone/>
+              <ns15:defRPr sz="1275" b="1">
+                <ns15:solidFill>
+                  <ns15:srgbClr val="FFFFFF"/>
+                </ns15:solidFill>
+                <ns15:latin typeface="Montserrat"/>
+                <ns15:ea typeface="Montserrat"/>
+                <ns15:cs typeface="Montserrat"/>
+              </ns15:defRPr>
+            </ns15:pPr>
+            <ns15:r>
+              <ns15:rPr sz="1200"/>
+              <ns15:t>04  WizardConnect keeps keys in the wallet</ns15:t>
+            </ns15:r>
+          </ns15:p>
         </p:txBody>
       </p:sp>
       <p:sp>
@@ -14158,8 +14367,8 @@
         </p:nvSpPr>
         <p:spPr>
           <a:xfrm xmlns:a="http://schemas.openxmlformats.org/drawingml/2006/main">
-            <a:off x="3714750" y="2571750"/>
-            <a:ext cx="38100" cy="1524000"/>
+            <a:off x="3712463" y="2121408"/>
+            <a:ext cx="38100" cy="2240280"/>
           </a:xfrm>
           <a:prstGeom xmlns:a="http://schemas.openxmlformats.org/drawingml/2006/main" prst="rect">
             <a:avLst/>
@@ -14189,7 +14398,7 @@
         </p:nvSpPr>
         <p:spPr>
           <a:xfrm xmlns:a="http://schemas.openxmlformats.org/drawingml/2006/main">
-            <a:off x="3952875" y="2571750"/>
+            <a:off x="3950208" y="2121408"/>
             <a:ext cx="2095500" cy="228600"/>
           </a:xfrm>
           <a:prstGeom xmlns:a="http://schemas.openxmlformats.org/drawingml/2006/main" prst="rect">
@@ -14329,7 +14538,7 @@
                 <a:ea typeface="Montserrat"/>
                 <a:cs typeface="Montserrat"/>
               </a:rPr>
-              <a:t>PRODUCT PATH</a:t>
+              <a:t>WHO PAYS</a:t>
             </a:r>
           </a:p>
         </p:txBody>
@@ -14350,8 +14559,8 @@
         </p:nvSpPr>
         <p:spPr>
           <a:xfrm xmlns:a="http://schemas.openxmlformats.org/drawingml/2006/main">
-            <a:off x="3952875" y="2886075"/>
-            <a:ext cx="4095750" cy="1066800"/>
+            <a:off x="3950208" y="2377440"/>
+            <a:ext cx="4480560" cy="1737360"/>
           </a:xfrm>
           <a:prstGeom xmlns:a="http://schemas.openxmlformats.org/drawingml/2006/main" prst="rect">
             <a:avLst/>
@@ -14466,87 +14675,114 @@
               </a:defRPr>
             </a:lvl9pPr>
           </a:lstStyle>
-          <a:p xmlns:a="http://schemas.openxmlformats.org/drawingml/2006/main">
-            <a:pPr algn="l">
-              <a:lnSpc>
-                <a:spcPct val="115000"/>
-              </a:lnSpc>
-              <a:buNone/>
-              <a:defRPr sz="1350" b="1">
-                <a:solidFill>
-                  <a:srgbClr val="FFFFFF"/>
-                </a:solidFill>
-                <a:latin typeface="Montserrat"/>
-                <a:ea typeface="Montserrat"/>
-                <a:cs typeface="Montserrat"/>
-              </a:defRPr>
-            </a:pPr>
-            <a:r>
-              <a:rPr sz="1350" b="1">
-                <a:solidFill>
-                  <a:srgbClr val="FFFFFF"/>
-                </a:solidFill>
-                <a:latin typeface="Montserrat"/>
-                <a:ea typeface="Montserrat"/>
-                <a:cs typeface="Montserrat"/>
-              </a:rPr>
-              <a:t>Hosted budget console</a:t>
-            </a:r>
-          </a:p>
-          <a:p xmlns:a="http://schemas.openxmlformats.org/drawingml/2006/main">
-            <a:pPr algn="l">
-              <a:lnSpc>
-                <a:spcPct val="115000"/>
-              </a:lnSpc>
-              <a:buNone/>
-              <a:defRPr sz="1350" b="1">
-                <a:solidFill>
-                  <a:srgbClr val="FFFFFF"/>
-                </a:solidFill>
-                <a:latin typeface="Montserrat"/>
-                <a:ea typeface="Montserrat"/>
-                <a:cs typeface="Montserrat"/>
-              </a:defRPr>
-            </a:pPr>
-            <a:r>
-              <a:rPr sz="1350" b="1">
-                <a:solidFill>
-                  <a:srgbClr val="FFFFFF"/>
-                </a:solidFill>
-                <a:latin typeface="Montserrat"/>
-                <a:ea typeface="Montserrat"/>
-                <a:cs typeface="Montserrat"/>
-              </a:rPr>
-              <a:t>Provider SDK</a:t>
-            </a:r>
-          </a:p>
-          <a:p xmlns:a="http://schemas.openxmlformats.org/drawingml/2006/main">
-            <a:pPr algn="l">
-              <a:lnSpc>
-                <a:spcPct val="115000"/>
-              </a:lnSpc>
-              <a:buNone/>
-              <a:defRPr sz="1350" b="1">
-                <a:solidFill>
-                  <a:srgbClr val="FFFFFF"/>
-                </a:solidFill>
-                <a:latin typeface="Montserrat"/>
-                <a:ea typeface="Montserrat"/>
-                <a:cs typeface="Montserrat"/>
-              </a:defRPr>
-            </a:pPr>
-            <a:r>
-              <a:rPr sz="1350" b="1">
-                <a:solidFill>
-                  <a:srgbClr val="FFFFFF"/>
-                </a:solidFill>
-                <a:latin typeface="Montserrat"/>
-                <a:ea typeface="Montserrat"/>
-                <a:cs typeface="Montserrat"/>
-              </a:rPr>
-              <a:t>Agent billing gateway</a:t>
-            </a:r>
-          </a:p>
+          <ns16:p xmlns:ns16="http://schemas.openxmlformats.org/drawingml/2006/main">
+            <ns16:pPr algn="l">
+              <ns16:lnSpc>
+                <ns16:spcPct val="110000"/>
+              </ns16:lnSpc>
+              <ns16:spcAft>
+                <ns16:spcPts val="900"/>
+              </ns16:spcAft>
+              <ns16:buNone/>
+              <ns16:defRPr sz="1350" b="1">
+                <ns16:solidFill>
+                  <ns16:srgbClr val="FFFFFF"/>
+                </ns16:solidFill>
+                <ns16:latin typeface="Montserrat"/>
+                <ns16:ea typeface="Montserrat"/>
+                <ns16:cs typeface="Montserrat"/>
+              </ns16:defRPr>
+            </ns16:pPr>
+            <ns16:r>
+              <ns16:rPr sz="1250" b="1">
+                <ns16:solidFill>
+                  <ns16:srgbClr val="FFFFFF"/>
+                </ns16:solidFill>
+              </ns16:rPr>
+              <ns16:t>Agent builders</ns16:t>
+            </ns16:r>
+            <ns16:br/>
+            <ns16:r>
+              <ns16:rPr sz="1050" b="0">
+                <ns16:solidFill>
+                  <ns16:srgbClr val="C9B8BB"/>
+                </ns16:solidFill>
+              </ns16:rPr>
+              <ns16:t>Budget console for agent fleets (subscription)</ns16:t>
+            </ns16:r>
+          </ns16:p>
+          <ns22:p xmlns:ns22="http://schemas.openxmlformats.org/drawingml/2006/main">
+            <ns22:pPr algn="l">
+              <ns22:lnSpc>
+                <ns22:spcPct val="110000"/>
+              </ns22:lnSpc>
+              <ns22:spcAft>
+                <ns22:spcPts val="900"/>
+              </ns22:spcAft>
+              <ns22:buNone/>
+              <ns22:defRPr sz="1350" b="1">
+                <ns22:solidFill>
+                  <ns22:srgbClr val="FFFFFF"/>
+                </ns22:solidFill>
+                <ns22:latin typeface="Montserrat"/>
+                <ns22:ea typeface="Montserrat"/>
+                <ns22:cs typeface="Montserrat"/>
+              </ns22:defRPr>
+            </ns22:pPr>
+            <ns22:r>
+              <ns22:rPr sz="1250" b="1">
+                <ns22:solidFill>
+                  <ns22:srgbClr val="FFFFFF"/>
+                </ns22:solidFill>
+              </ns22:rPr>
+              <ns22:t>API &amp; MCP tool providers</ns22:t>
+            </ns22:r>
+            <ns22:br/>
+            <ns22:r>
+              <ns22:rPr sz="1050" b="0">
+                <ns22:solidFill>
+                  <ns22:srgbClr val="C9B8BB"/>
+                </ns22:solidFill>
+              </ns22:rPr>
+              <ns22:t>SDK that verifies each $0.01 PUSD call</ns22:t>
+            </ns22:r>
+          </ns22:p>
+          <ns28:p xmlns:ns28="http://schemas.openxmlformats.org/drawingml/2006/main">
+            <ns28:pPr algn="l">
+              <ns28:lnSpc>
+                <ns28:spcPct val="110000"/>
+              </ns28:lnSpc>
+              <ns28:spcAft>
+                <ns28:spcPts val="0"/>
+              </ns28:spcAft>
+              <ns28:buNone/>
+              <ns28:defRPr sz="1350" b="1">
+                <ns28:solidFill>
+                  <ns28:srgbClr val="FFFFFF"/>
+                </ns28:solidFill>
+                <ns28:latin typeface="Montserrat"/>
+                <ns28:ea typeface="Montserrat"/>
+                <ns28:cs typeface="Montserrat"/>
+              </ns28:defRPr>
+            </ns28:pPr>
+            <ns28:r>
+              <ns28:rPr sz="1250" b="1">
+                <ns28:solidFill>
+                  <ns28:srgbClr val="FFFFFF"/>
+                </ns28:solidFill>
+              </ns28:rPr>
+              <ns28:t>Hosted gateway</ns28:t>
+            </ns28:r>
+            <ns28:br/>
+            <ns28:r>
+              <ns28:rPr sz="1050" b="0">
+                <ns28:solidFill>
+                  <ns28:srgbClr val="C9B8BB"/>
+                </ns28:solidFill>
+              </ns28:rPr>
+              <ns28:t>Small fee per verified call; self-hosting is free</ns28:t>
+            </ns28:r>
+          </ns28:p>
         </p:txBody>
       </p:sp>
       <p:sp>
@@ -14565,8 +14801,8 @@
         </p:nvSpPr>
         <p:spPr>
           <a:xfrm xmlns:a="http://schemas.openxmlformats.org/drawingml/2006/main">
-            <a:off x="3952875" y="4095750"/>
-            <a:ext cx="4095750" cy="228600"/>
+            <a:off x="3950208" y="4114800"/>
+            <a:ext cx="4480560" cy="384048"/>
           </a:xfrm>
           <a:prstGeom xmlns:a="http://schemas.openxmlformats.org/drawingml/2006/main" prst="rect">
             <a:avLst/>
@@ -14681,33 +14917,46 @@
               </a:defRPr>
             </a:lvl9pPr>
           </a:lstStyle>
-          <a:p xmlns:a="http://schemas.openxmlformats.org/drawingml/2006/main">
-            <a:pPr algn="l">
-              <a:lnSpc>
-                <a:spcPct val="108000"/>
-              </a:lnSpc>
-              <a:buNone/>
-              <a:defRPr sz="1050" b="0">
-                <a:solidFill>
-                  <a:srgbClr val="B9A6A9"/>
-                </a:solidFill>
-                <a:latin typeface="Montserrat"/>
-                <a:ea typeface="Montserrat"/>
-                <a:cs typeface="Montserrat"/>
-              </a:defRPr>
-            </a:pPr>
-            <a:r>
-              <a:rPr sz="1050" b="0">
-                <a:solidFill>
-                  <a:srgbClr val="B9A6A9"/>
-                </a:solidFill>
-                <a:latin typeface="Montserrat"/>
-                <a:ea typeface="Montserrat"/>
-                <a:cs typeface="Montserrat"/>
-              </a:rPr>
-              <a:t>No protocol fee in the covenant.</a:t>
-            </a:r>
-          </a:p>
+          <ns34:p xmlns:ns34="http://schemas.openxmlformats.org/drawingml/2006/main">
+            <ns34:pPr algn="l">
+              <ns34:lnSpc>
+                <ns34:spcPct val="108000"/>
+              </ns34:lnSpc>
+              <ns34:buNone/>
+              <ns34:defRPr sz="1050" b="0">
+                <ns34:solidFill>
+                  <ns34:srgbClr val="B9A6A9"/>
+                </ns34:solidFill>
+                <ns34:latin typeface="Montserrat"/>
+                <ns34:ea typeface="Montserrat"/>
+                <ns34:cs typeface="Montserrat"/>
+              </ns34:defRPr>
+            </ns34:pPr>
+            <ns34:r>
+              <ns34:rPr sz="1050"/>
+              <ns34:t>No protocol fee in the covenant.</ns34:t>
+            </ns34:r>
+          </ns34:p>
+          <ns35:p xmlns:ns35="http://schemas.openxmlformats.org/drawingml/2006/main">
+            <ns35:pPr algn="l">
+              <ns35:lnSpc>
+                <ns35:spcPct val="108000"/>
+              </ns35:lnSpc>
+              <ns35:buNone/>
+              <ns35:defRPr sz="1050" b="0">
+                <ns35:solidFill>
+                  <ns35:srgbClr val="B9A6A9"/>
+                </ns35:solidFill>
+                <ns35:latin typeface="Montserrat"/>
+                <ns35:ea typeface="Montserrat"/>
+                <ns35:cs typeface="Montserrat"/>
+              </ns35:defRPr>
+            </ns35:pPr>
+            <ns35:r>
+              <ns35:rPr sz="1050"/>
+              <ns35:t>First market: paid MCP tools and data APIs.</ns35:t>
+            </ns35:r>
+          </ns35:p>
         </p:txBody>
       </p:sp>
     </p:spTree>
@@ -15596,7 +15845,7 @@
                 <a:ea typeface="Montserrat"/>
                 <a:cs typeface="Montserrat"/>
               </a:rPr>
-              <a:t>Live demo   /   Google Slides   /   GitHub</a:t>
+              <a:t>Live demo   /   Deck PDF   /   GitHub</a:t>
             </a:r>
           </a:p>
         </p:txBody>

</xml_diff>